<commit_message>
Implement Figma Present verification and retest updates for 30-minute expiry; adjust prototype documentation and model tests accordingly. - Added Figma Present-mode check documentation for 30 October 2026. - Verified transitions and identified open defects in the Figma prototype. - Updated interactive reward examples with new screens and tested transitions. - Changed expiry duration from 45 minutes to 30 minutes in the prototype and updated related tests. - Adjusted UI smoke tests to reflect new expiry timing.
</commit_message>
<xml_diff>
--- a/SilentBeacon_Defense_Ready_Draft.pptx
+++ b/SilentBeacon_Defense_Ready_Draft.pptx
@@ -2,22 +2,22 @@
 <file path=ppt/presentation.xml><?xml version="1.0" encoding="utf-8"?>
 <p:presentation xmlns:p="http://schemas.openxmlformats.org/presentationml/2006/main">
   <p:sldMasterIdLst>
-    <p:sldMasterId xmlns:r="http://schemas.openxmlformats.org/officeDocument/2006/relationships" id="2147483648" r:id="Rc7d77d1c25624ab9"/>
+    <p:sldMasterId xmlns:r="http://schemas.openxmlformats.org/officeDocument/2006/relationships" id="2147483648" r:id="R5ae66cf437784620"/>
   </p:sldMasterIdLst>
   <p:notesMasterIdLst>
-    <p:notesMasterId xmlns:r="http://schemas.openxmlformats.org/officeDocument/2006/relationships" r:id="R06ee5feb7cf8499e"/>
+    <p:notesMasterId xmlns:r="http://schemas.openxmlformats.org/officeDocument/2006/relationships" r:id="R7a313d02b2704155"/>
   </p:notesMasterIdLst>
   <p:sldIdLst>
-    <p:sldId xmlns:r="http://schemas.openxmlformats.org/officeDocument/2006/relationships" id="256" r:id="R4f44cf613afb43f9"/>
-    <p:sldId xmlns:r="http://schemas.openxmlformats.org/officeDocument/2006/relationships" id="257" r:id="R1a912e0d12a54009"/>
-    <p:sldId xmlns:r="http://schemas.openxmlformats.org/officeDocument/2006/relationships" id="258" r:id="R314206c5c27b4e8e"/>
-    <p:sldId xmlns:r="http://schemas.openxmlformats.org/officeDocument/2006/relationships" id="259" r:id="Ra5a14f9e6bf74df7"/>
-    <p:sldId xmlns:r="http://schemas.openxmlformats.org/officeDocument/2006/relationships" id="260" r:id="R9e3d067916c3432d"/>
-    <p:sldId xmlns:r="http://schemas.openxmlformats.org/officeDocument/2006/relationships" id="261" r:id="R15645daf10884095"/>
-    <p:sldId xmlns:r="http://schemas.openxmlformats.org/officeDocument/2006/relationships" id="262" r:id="Rc551509393234cdb"/>
-    <p:sldId xmlns:r="http://schemas.openxmlformats.org/officeDocument/2006/relationships" id="263" r:id="R7a69f22c0fa146e6"/>
-    <p:sldId xmlns:r="http://schemas.openxmlformats.org/officeDocument/2006/relationships" id="264" r:id="R168a959ca40e4b6c"/>
-    <p:sldId xmlns:r="http://schemas.openxmlformats.org/officeDocument/2006/relationships" id="265" r:id="R5c13cba093284f38"/>
+    <p:sldId xmlns:r="http://schemas.openxmlformats.org/officeDocument/2006/relationships" id="256" r:id="R91f5640393404fd8"/>
+    <p:sldId xmlns:r="http://schemas.openxmlformats.org/officeDocument/2006/relationships" id="257" r:id="Rd26eda6a4b4b4db3"/>
+    <p:sldId xmlns:r="http://schemas.openxmlformats.org/officeDocument/2006/relationships" id="258" r:id="R0bebfcb51c724314"/>
+    <p:sldId xmlns:r="http://schemas.openxmlformats.org/officeDocument/2006/relationships" id="259" r:id="R4beea6701fac4098"/>
+    <p:sldId xmlns:r="http://schemas.openxmlformats.org/officeDocument/2006/relationships" id="260" r:id="Ra6d8ec222cf84623"/>
+    <p:sldId xmlns:r="http://schemas.openxmlformats.org/officeDocument/2006/relationships" id="261" r:id="Rf1580591ff9f4597"/>
+    <p:sldId xmlns:r="http://schemas.openxmlformats.org/officeDocument/2006/relationships" id="262" r:id="Ra3f3ec7adf234c27"/>
+    <p:sldId xmlns:r="http://schemas.openxmlformats.org/officeDocument/2006/relationships" id="263" r:id="Rc2d35c84e4fb466f"/>
+    <p:sldId xmlns:r="http://schemas.openxmlformats.org/officeDocument/2006/relationships" id="264" r:id="R18dc3663fab048b3"/>
+    <p:sldId xmlns:r="http://schemas.openxmlformats.org/officeDocument/2006/relationships" id="265" r:id="R622d480aba1443c7"/>
   </p:sldIdLst>
   <p:sldSz cx="12192000" cy="6858000"/>
   <p:notesSz cx="6858000" cy="9144000"/>
@@ -451,7 +451,7 @@
           <a:lstStyle xmlns:a="http://schemas.openxmlformats.org/drawingml/2006/main"/>
           <a:p xmlns:a="http://schemas.openxmlformats.org/drawingml/2006/main">
             <a:r>
-              <a:t>Source: SilentBeacon Agile Project Plan SE2416; project documentation and verified Trello/Figma records prepared 29 October 2026. Prior design reference: SilentBeacon Updated Presentation.</a:t>
+              <a:t>Source: SilentBeacon Agile Endterm report (30 October 2026); project documentation and verified Trello/Figma records prepared 29 October 2026. Prior design reference: SilentBeacon Updated Presentation.</a:t>
             </a:r>
           </a:p>
           <a:p xmlns:a="http://schemas.openxmlformats.org/drawingml/2006/main">
@@ -531,7 +531,7 @@
           <a:lstStyle xmlns:a="http://schemas.openxmlformats.org/drawingml/2006/main"/>
           <a:p xmlns:a="http://schemas.openxmlformats.org/drawingml/2006/main">
             <a:r>
-              <a:t>Source: SilentBeacon Agile Project Plan SE2416; project documentation and verified Trello/Figma records prepared 29 October 2026. Prior design reference: SilentBeacon Updated Presentation. GitHub repository: https://github.com/nalrematvonessahk/silentbeacon-agile-project</a:t>
+              <a:t>Source: SilentBeacon Agile Endterm report (30 October 2026); project documentation and verified Trello/Figma records prepared 29 October 2026. Prior design reference: SilentBeacon Updated Presentation. GitHub repository: https://github.com/nalrematvonessahk/silentbeacon-agile-project</a:t>
             </a:r>
           </a:p>
           <a:p xmlns:a="http://schemas.openxmlformats.org/drawingml/2006/main">
@@ -611,7 +611,7 @@
           <a:lstStyle xmlns:a="http://schemas.openxmlformats.org/drawingml/2006/main"/>
           <a:p xmlns:a="http://schemas.openxmlformats.org/drawingml/2006/main">
             <a:r>
-              <a:t>Source: SilentBeacon Agile Project Plan SE2416; project documentation and verified Trello/Figma records prepared 29 October 2026. Prior design reference: SilentBeacon Updated Presentation.</a:t>
+              <a:t>Source: SilentBeacon Agile Endterm report (30 October 2026); project documentation and verified Trello/Figma records prepared 29 October 2026. Prior design reference: SilentBeacon Updated Presentation.</a:t>
             </a:r>
           </a:p>
           <a:p xmlns:a="http://schemas.openxmlformats.org/drawingml/2006/main">
@@ -691,7 +691,7 @@
           <a:lstStyle xmlns:a="http://schemas.openxmlformats.org/drawingml/2006/main"/>
           <a:p xmlns:a="http://schemas.openxmlformats.org/drawingml/2006/main">
             <a:r>
-              <a:t>Source: SilentBeacon Agile Project Plan SE2416; project documentation and verified Trello/Figma records prepared 29 October 2026. Prior design reference: SilentBeacon Updated Presentation. Figma prototype is a series of preset scenarios, not a live service.</a:t>
+              <a:t>Source: SilentBeacon Agile Endterm report (30 October 2026); project documentation and verified Trello/Figma records prepared 29 October 2026. Prior design reference: SilentBeacon Updated Presentation. Figma prototype is a series of preset scenarios, not a live service.</a:t>
             </a:r>
           </a:p>
           <a:p xmlns:a="http://schemas.openxmlformats.org/drawingml/2006/main">
@@ -771,7 +771,7 @@
           <a:lstStyle xmlns:a="http://schemas.openxmlformats.org/drawingml/2006/main"/>
           <a:p xmlns:a="http://schemas.openxmlformats.org/drawingml/2006/main">
             <a:r>
-              <a:t>Source: SilentBeacon Agile Project Plan SE2416; project documentation and verified Trello/Figma records prepared 29 October 2026. Prior design reference: SilentBeacon Updated Presentation.</a:t>
+              <a:t>Source: SilentBeacon Agile Endterm report (30 October 2026); project documentation and verified Trello/Figma records prepared 29 October 2026. Prior design reference: SilentBeacon Updated Presentation.</a:t>
             </a:r>
           </a:p>
           <a:p xmlns:a="http://schemas.openxmlformats.org/drawingml/2006/main">
@@ -781,7 +781,7 @@
           </a:p>
           <a:p xmlns:a="http://schemas.openxmlformats.org/drawingml/2006/main">
             <a:r>
-              <a:t>Suggested presenter: Tamerlan. Contrast an example at 44:59 with one at 45:00. Noise and outlet observations are separate. The prototype depicts expiry but does not run a server clock, validate networks, record audio or persist reports.</a:t>
+              <a:t>Suggested presenter: Tamerlan. The report sets expiry at 30 minutes. Figma and the local demonstration show the 29:59 and 30:00 boundary. Figma expiry screens were visually inspected in desktop and narrow web sizes. A complete Present-mode walkthrough and team review remain pending. Noise and outlet observations have separate timestamps. No server validation or persistence is claimed.</a:t>
             </a:r>
           </a:p>
         </p:txBody>
@@ -851,7 +851,7 @@
           <a:lstStyle xmlns:a="http://schemas.openxmlformats.org/drawingml/2006/main"/>
           <a:p xmlns:a="http://schemas.openxmlformats.org/drawingml/2006/main">
             <a:r>
-              <a:t>Source: SilentBeacon Agile Project Plan SE2416; project documentation and verified Trello/Figma records prepared 29 October 2026. Prior design reference: SilentBeacon Updated Presentation. Board evidence: https://trello.com/b/cn7omEzN/silentbeacon-agile-project-management-se-2416</a:t>
+              <a:t>Source: SilentBeacon Agile Endterm report (30 October 2026); project documentation and verified Trello/Figma records prepared 29 October 2026. Prior design reference: SilentBeacon Updated Presentation. Board evidence: https://trello.com/b/cn7omEzN/silentbeacon-agile-project-management-se-2416</a:t>
             </a:r>
           </a:p>
           <a:p xmlns:a="http://schemas.openxmlformats.org/drawingml/2006/main">
@@ -861,7 +861,7 @@
           </a:p>
           <a:p xmlns:a="http://schemas.openxmlformats.org/drawingml/2006/main">
             <a:r>
-              <a:t>Suggested presenter: Askhat. Open the real Trello board: https://trello.com/b/cn7omEzN/silentbeacon-agile-project-management-se-2416 . The 48 tasks were initially unchecked and the four Sprint 1 cards were staged as a draft. Check the live board for current status before presenting; story estimates are not delivery evidence.</a:t>
+              <a:t>Suggested presenter: Askhat. Open the real Trello board: https://trello.com/b/cn7omEzN/silentbeacon-agile-project-management-se-2416 . Three Sprint 1 stories have assistant-created draft work and appear in progress. Team assignments remain unconfirmed. Check the live board for current status before presenting; story estimates are not delivery evidence.</a:t>
             </a:r>
           </a:p>
         </p:txBody>
@@ -931,7 +931,7 @@
           <a:lstStyle xmlns:a="http://schemas.openxmlformats.org/drawingml/2006/main"/>
           <a:p xmlns:a="http://schemas.openxmlformats.org/drawingml/2006/main">
             <a:r>
-              <a:t>Source: SilentBeacon Agile Project Plan SE2416; project documentation and verified Trello/Figma records prepared 29 October 2026. Prior design reference: SilentBeacon Updated Presentation.</a:t>
+              <a:t>Source: SilentBeacon Agile Endterm report (30 October 2026); project documentation and verified Trello/Figma records prepared 29 October 2026. Prior design reference: SilentBeacon Updated Presentation.</a:t>
             </a:r>
           </a:p>
           <a:p xmlns:a="http://schemas.openxmlformats.org/drawingml/2006/main">
@@ -941,7 +941,7 @@
           </a:p>
           <a:p xmlns:a="http://schemas.openxmlformats.org/drawingml/2006/main">
             <a:r>
-              <a:t>Suggested presenter: Askhat. State the exact user-specified dates and original allocations of 21 story points per sprint. The source plan estimated a two-week capacity; the compressed schedule requires the team to confirm availability and a feasible forecast.</a:t>
+              <a:t>Suggested presenter: Askhat. The report proposes three three-week sprints. At eight hours per week for five members the nine-week forecast is 360 hours, including 270 delivery, 63 coordination and 27 contingency hours. The defense is an interim checkpoint on November 13; the project continues until December 24. Actual availability and scope remain unconfirmed.</a:t>
             </a:r>
           </a:p>
         </p:txBody>
@@ -1011,7 +1011,7 @@
           <a:lstStyle xmlns:a="http://schemas.openxmlformats.org/drawingml/2006/main"/>
           <a:p xmlns:a="http://schemas.openxmlformats.org/drawingml/2006/main">
             <a:r>
-              <a:t>Source: SilentBeacon Agile Project Plan SE2416; project documentation and verified Trello/Figma records prepared 29 October 2026. Prior design reference: SilentBeacon Updated Presentation. Figma: https://www.figma.com/design/spEnordZysj72nrb1p28kb</a:t>
+              <a:t>Source: SilentBeacon Agile Endterm report (30 October 2026); project documentation and verified Trello/Figma records prepared 29 October 2026. Prior design reference: SilentBeacon Updated Presentation. Figma: https://www.figma.com/design/spEnordZysj72nrb1p28kb</a:t>
             </a:r>
           </a:p>
           <a:p xmlns:a="http://schemas.openxmlformats.org/drawingml/2006/main">
@@ -1021,7 +1021,7 @@
           </a:p>
           <a:p xmlns:a="http://schemas.openxmlformats.org/drawingml/2006/main">
             <a:r>
-              <a:t>Suggested presenter: Merey. Open the editable file https://www.figma.com/design/spEnordZysj72nrb1p28kb . The figures describe the created design, not verified usability. Social GPA is proposed and simulated, subject to university approval; analytics use demonstration data. A human Present-mode and keyboard walkthrough still needs evidence.</a:t>
+              <a:t>Suggested presenter: Merey. Open the editable file https://www.figma.com/design/spEnordZysj72nrb1p28kb . The figures describe the created design, not verified usability. Social GPA is proposed and simulated, subject to university approval; analytics use demonstration data. A human Present-mode and keyboard walkthrough still needs evidence. The Figma expiry screens were updated to 30 minutes and visually inspected in desktop and narrow web sizes. A full Present-mode walkthrough and team review remain pending.</a:t>
             </a:r>
           </a:p>
         </p:txBody>
@@ -1091,7 +1091,7 @@
           <a:lstStyle xmlns:a="http://schemas.openxmlformats.org/drawingml/2006/main"/>
           <a:p xmlns:a="http://schemas.openxmlformats.org/drawingml/2006/main">
             <a:r>
-              <a:t>Source: SilentBeacon Agile Project Plan SE2416; project documentation and verified Trello/Figma records prepared 29 October 2026. Prior design reference: SilentBeacon Updated Presentation.</a:t>
+              <a:t>Source: SilentBeacon Agile Endterm report (30 October 2026); project documentation and verified Trello/Figma records prepared 29 October 2026. Prior design reference: SilentBeacon Updated Presentation.</a:t>
             </a:r>
           </a:p>
           <a:p xmlns:a="http://schemas.openxmlformats.org/drawingml/2006/main">
@@ -1171,7 +1171,7 @@
           <a:lstStyle xmlns:a="http://schemas.openxmlformats.org/drawingml/2006/main"/>
           <a:p xmlns:a="http://schemas.openxmlformats.org/drawingml/2006/main">
             <a:r>
-              <a:t>Source: SilentBeacon Agile Project Plan SE2416; project documentation and verified Trello/Figma records prepared 29 October 2026. Prior design reference: SilentBeacon Updated Presentation.</a:t>
+              <a:t>Source: SilentBeacon Agile Endterm report (30 October 2026); project documentation and verified Trello/Figma records prepared 29 October 2026. Prior design reference: SilentBeacon Updated Presentation.</a:t>
             </a:r>
           </a:p>
           <a:p xmlns:a="http://schemas.openxmlformats.org/drawingml/2006/main">
@@ -3624,12 +3624,12 @@
   </p:cSld>
   <p:clrMap bg1="lt1" tx1="dk1" bg2="lt2" tx2="dk2" accent1="accent1" accent2="accent2" accent3="accent3" accent4="accent4" accent5="accent5" accent6="accent6" hlink="hlink" folHlink="folHlink"/>
   <p:sldLayoutIdLst>
-    <p:sldLayoutId xmlns:r="http://schemas.openxmlformats.org/officeDocument/2006/relationships" id="2147483649" r:id="R4d9e6586ca274a4d"/>
-    <p:sldLayoutId xmlns:r="http://schemas.openxmlformats.org/officeDocument/2006/relationships" id="2147483650" r:id="Rad7410d99ec947f0"/>
-    <p:sldLayoutId xmlns:r="http://schemas.openxmlformats.org/officeDocument/2006/relationships" id="2147483651" r:id="R183660f6edee4b59"/>
-    <p:sldLayoutId xmlns:r="http://schemas.openxmlformats.org/officeDocument/2006/relationships" id="2147483652" r:id="Rc4fa216f11ab417d"/>
-    <p:sldLayoutId xmlns:r="http://schemas.openxmlformats.org/officeDocument/2006/relationships" id="2147483653" r:id="R05886d0d71cb41f5"/>
-    <p:sldLayoutId xmlns:r="http://schemas.openxmlformats.org/officeDocument/2006/relationships" id="2147483654" r:id="Rac1fda1df339408a"/>
+    <p:sldLayoutId xmlns:r="http://schemas.openxmlformats.org/officeDocument/2006/relationships" id="2147483649" r:id="R16c68806079241bb"/>
+    <p:sldLayoutId xmlns:r="http://schemas.openxmlformats.org/officeDocument/2006/relationships" id="2147483650" r:id="R8215d9093748406f"/>
+    <p:sldLayoutId xmlns:r="http://schemas.openxmlformats.org/officeDocument/2006/relationships" id="2147483651" r:id="R14b20233fd404e40"/>
+    <p:sldLayoutId xmlns:r="http://schemas.openxmlformats.org/officeDocument/2006/relationships" id="2147483652" r:id="R8fe6dbbecf5a478c"/>
+    <p:sldLayoutId xmlns:r="http://schemas.openxmlformats.org/officeDocument/2006/relationships" id="2147483653" r:id="R607fa8c297d24695"/>
+    <p:sldLayoutId xmlns:r="http://schemas.openxmlformats.org/officeDocument/2006/relationships" id="2147483654" r:id="R88f5d91be95c412e"/>
   </p:sldLayoutIdLst>
   <p:txStyles>
     <p:titleStyle>
@@ -6073,7 +6073,7 @@
                 <a:ea typeface="Arial"/>
                 <a:cs typeface="Arial"/>
               </a:rPr>
-              <a:t>Confirm availability and select a feasible forecast for shortened sprints.</a:t>
+              <a:t>Confirm availability and select a feasible three-week sprint forecast.</a:t>
             </a:r>
           </a:p>
         </p:txBody>
@@ -11306,7 +11306,7 @@
                 <a:ea typeface="Arial"/>
                 <a:cs typeface="Arial"/>
               </a:rPr>
-              <a:t>45 min</a:t>
+              <a:t>30 min</a:t>
             </a:r>
           </a:p>
         </p:txBody>
@@ -13825,7 +13825,7 @@
                 <a:ea typeface="Arial"/>
                 <a:cs typeface="Arial"/>
               </a:rPr>
-              <a:t>48</a:t>
+              <a:t>3</a:t>
             </a:r>
           </a:p>
         </p:txBody>
@@ -13991,7 +13991,7 @@
                 <a:ea typeface="Arial"/>
                 <a:cs typeface="Arial"/>
               </a:rPr>
-              <a:t>unchecked proposed tasks</a:t>
+              <a:t>stories with work started</a:t>
             </a:r>
           </a:p>
         </p:txBody>
@@ -14157,7 +14157,7 @@
                 <a:ea typeface="Arial"/>
                 <a:cs typeface="Arial"/>
               </a:rPr>
-              <a:t>Seven lists support the workflow from Product Backlog to Done. Four Sprint 1 cards are staged as a draft forecast.</a:t>
+              <a:t>Seven lists show the workflow. Sprint 1 remains a draft forecast awaiting team agreement.</a:t>
             </a:r>
           </a:p>
         </p:txBody>
@@ -15182,7 +15182,7 @@
                 <a:ea typeface="Arial"/>
                 <a:cs typeface="Arial"/>
               </a:rPr>
-              <a:t>October 26–31   ·   US01–US04   ·   21 SP</a:t>
+              <a:t>October 23–November 12   ·   US01–US04   ·   21 SP</a:t>
             </a:r>
           </a:p>
           <a:p xmlns:a="http://schemas.openxmlformats.org/drawingml/2006/main">
@@ -15538,7 +15538,7 @@
                 <a:ea typeface="Arial"/>
                 <a:cs typeface="Arial"/>
               </a:rPr>
-              <a:t>November 1–6   ·   US05–US08   ·   21 SP</a:t>
+              <a:t>November 13–December 3   ·   US05–US08   ·   21 SP</a:t>
             </a:r>
           </a:p>
           <a:p xmlns:a="http://schemas.openxmlformats.org/drawingml/2006/main">
@@ -15562,7 +15562,7 @@
                 <a:ea typeface="Arial"/>
                 <a:cs typeface="Arial"/>
               </a:rPr>
-              <a:t>Eligibility feedback and freshness</a:t>
+              <a:t>Trustworthy reports and freshness</a:t>
             </a:r>
           </a:p>
         </p:txBody>
@@ -15894,7 +15894,7 @@
                 <a:ea typeface="Arial"/>
                 <a:cs typeface="Arial"/>
               </a:rPr>
-              <a:t>November 7–12   ·   US09–US12   ·   21 SP</a:t>
+              <a:t>December 4–24   ·   US09–US12   ·   21 SP</a:t>
             </a:r>
           </a:p>
           <a:p xmlns:a="http://schemas.openxmlformats.org/drawingml/2006/main">
@@ -15918,7 +15918,7 @@
                 <a:ea typeface="Arial"/>
                 <a:cs typeface="Arial"/>
               </a:rPr>
-              <a:t>Sampling concept and release evidence</a:t>
+              <a:t>Rewards, campus insights and release</a:t>
             </a:r>
           </a:p>
         </p:txBody>
@@ -16084,7 +16084,7 @@
                 <a:ea typeface="Arial"/>
                 <a:cs typeface="Arial"/>
               </a:rPr>
-              <a:t>Revised six-day capacity and the team’s forecast still need confirmation.</a:t>
+              <a:t>Defense: November 13. The team must confirm its forecast.</a:t>
             </a:r>
           </a:p>
         </p:txBody>
@@ -16250,7 +16250,7 @@
                 <a:ea typeface="Arial"/>
                 <a:cs typeface="Arial"/>
               </a:rPr>
-              <a:t>Original two-week capacity assumptions do not transfer automatically</a:t>
+              <a:t>Planning assumption: 5 people × 8 hours/week × 9 weeks = 360 hours</a:t>
             </a:r>
           </a:p>
         </p:txBody>
@@ -18105,7 +18105,7 @@
                 <a:ea typeface="Arial"/>
                 <a:cs typeface="Arial"/>
               </a:rPr>
-              <a:t>Human Present-mode walkthrough and keyboard review are planned</a:t>
+              <a:t>Figma shows 30-minute expiry. Present-mode review is pending.</a:t>
             </a:r>
           </a:p>
         </p:txBody>

</xml_diff>